<commit_message>
docs: append et.19 qwen 4-variant addendum to PPT/Word
</commit_message>
<xml_diff>
--- a/docs/LocalDream-ET_更新修复说明_et18.pptx
+++ b/docs/LocalDream-ET_更新修复说明_et18.pptx
@@ -19,6 +19,7 @@
     <p:sldId id="267" r:id="rId18"/>
     <p:sldId id="268" r:id="rId19"/>
     <p:sldId id="269" r:id="rId20"/>
+    <p:sldId id="270" r:id="rId21"/>
   </p:sldIdLst>
   <p:sldSz cx="12191695" cy="6858000" type="screen4x3"/>
   <p:notesSz cx="6858000" cy="9144000"/>
@@ -4351,6 +4352,258 @@
                 <a:cs typeface="Microsoft YaHei"/>
               </a:rPr>
               <a:t>开发者：ET（广东·梅州）· GitHub: ETQWFD/LocalDream-ET · MIT License</a:t>
+            </a:r>
+          </a:p>
+        </p:txBody>
+      </p:sp>
+    </p:spTree>
+  </p:cSld>
+  <p:clrMapOvr>
+    <a:masterClrMapping/>
+  </p:clrMapOvr>
+</p:sld>
+</file>
+
+<file path=ppt/slides/slide15.xml><?xml version="1.0" encoding="utf-8"?>
+<p:sld xmlns:a="http://schemas.openxmlformats.org/drawingml/2006/main" xmlns:p="http://schemas.openxmlformats.org/presentationml/2006/main" xmlns:r="http://schemas.openxmlformats.org/officeDocument/2006/relationships">
+  <p:cSld>
+    <p:bg>
+      <p:bgPr>
+        <a:solidFill>
+          <a:srgbClr val="0B1117"/>
+        </a:solidFill>
+        <a:effectLst/>
+      </p:bgPr>
+    </p:bg>
+    <p:spTree>
+      <p:nvGrpSpPr>
+        <p:cNvPr id="1" name=""/>
+        <p:cNvGrpSpPr/>
+        <p:nvPr/>
+      </p:nvGrpSpPr>
+      <p:grpSpPr/>
+      <p:sp>
+        <p:nvSpPr>
+          <p:cNvPr id="2" name="TextBox 1"/>
+          <p:cNvSpPr txBox="1"/>
+          <p:nvPr/>
+        </p:nvSpPr>
+        <p:spPr>
+          <a:xfrm>
+            <a:off x="640080" y="457200"/>
+            <a:ext cx="10972800" cy="822960"/>
+          </a:xfrm>
+          <a:prstGeom prst="rect">
+            <a:avLst/>
+          </a:prstGeom>
+          <a:noFill/>
+        </p:spPr>
+        <p:txBody>
+          <a:bodyPr wrap="square">
+            <a:spAutoFit/>
+          </a:bodyPr>
+          <a:lstStyle/>
+          <a:p>
+            <a:pPr>
+              <a:spcAft>
+                <a:spcPts val="600"/>
+              </a:spcAft>
+            </a:pPr>
+            <a:r>
+              <a:rPr sz="3000" b="1">
+                <a:solidFill>
+                  <a:srgbClr val="2DD4BF"/>
+                </a:solidFill>
+                <a:latin typeface="Microsoft YaHei"/>
+                <a:ea typeface="Microsoft YaHei"/>
+                <a:cs typeface="Microsoft YaHei"/>
+              </a:rPr>
+              <a:t>增补：v3.0.0-et.19（build 93）</a:t>
+            </a:r>
+          </a:p>
+        </p:txBody>
+      </p:sp>
+      <p:sp>
+        <p:nvSpPr>
+          <p:cNvPr id="3" name="TextBox 2"/>
+          <p:cNvSpPr txBox="1"/>
+          <p:nvPr/>
+        </p:nvSpPr>
+        <p:spPr>
+          <a:xfrm>
+            <a:off x="640080" y="1463040"/>
+            <a:ext cx="10972800" cy="4572000"/>
+          </a:xfrm>
+          <a:prstGeom prst="rect">
+            <a:avLst/>
+          </a:prstGeom>
+          <a:noFill/>
+        </p:spPr>
+        <p:txBody>
+          <a:bodyPr wrap="square">
+            <a:spAutoFit/>
+          </a:bodyPr>
+          <a:lstStyle/>
+          <a:p>
+            <a:pPr>
+              <a:spcAft>
+                <a:spcPts val="600"/>
+              </a:spcAft>
+            </a:pPr>
+            <a:r>
+              <a:rPr sz="1800" b="1">
+                <a:solidFill>
+                  <a:srgbClr val="E8EEF4"/>
+                </a:solidFill>
+                <a:latin typeface="Microsoft YaHei"/>
+                <a:ea typeface="Microsoft YaHei"/>
+                <a:cs typeface="Microsoft YaHei"/>
+              </a:rPr>
+              <a:t>千问 Qwen Image 2.1 补齐为 4 个可下载模型：</a:t>
+            </a:r>
+          </a:p>
+          <a:p>
+            <a:pPr>
+              <a:spcAft>
+                <a:spcPts val="600"/>
+              </a:spcAft>
+            </a:pPr>
+            <a:r>
+              <a:rPr sz="1500" b="0">
+                <a:solidFill>
+                  <a:srgbClr val="E8EEF4"/>
+                </a:solidFill>
+                <a:latin typeface="Microsoft YaHei"/>
+                <a:ea typeface="Microsoft YaHei"/>
+                <a:cs typeface="Microsoft YaHei"/>
+              </a:rPr>
+              <a:t>1) Q3_K 最小版（新）：DiT 3.27GB，整包约 9.9GB，千问中最省空间/最快；</a:t>
+            </a:r>
+          </a:p>
+          <a:p>
+            <a:pPr>
+              <a:spcAft>
+                <a:spcPts val="600"/>
+              </a:spcAft>
+            </a:pPr>
+            <a:r>
+              <a:rPr sz="1500" b="0">
+                <a:solidFill>
+                  <a:srgbClr val="E8EEF4"/>
+                </a:solidFill>
+                <a:latin typeface="Microsoft YaHei"/>
+                <a:ea typeface="Microsoft YaHei"/>
+                <a:cs typeface="Microsoft YaHei"/>
+              </a:rPr>
+              <a:t>2) 标准 Q4_0：DiT 4.20GB，整包约 10.8GB；</a:t>
+            </a:r>
+          </a:p>
+          <a:p>
+            <a:pPr>
+              <a:spcAft>
+                <a:spcPts val="600"/>
+              </a:spcAft>
+            </a:pPr>
+            <a:r>
+              <a:rPr sz="1500" b="0">
+                <a:solidFill>
+                  <a:srgbClr val="E8EEF4"/>
+                </a:solidFill>
+                <a:latin typeface="Microsoft YaHei"/>
+                <a:ea typeface="Microsoft YaHei"/>
+                <a:cs typeface="Microsoft YaHei"/>
+              </a:rPr>
+              <a:t>3) 无审查 UC Q4_0：DiT 4.15GB，整包约 10.8GB；</a:t>
+            </a:r>
+          </a:p>
+          <a:p>
+            <a:pPr>
+              <a:spcAft>
+                <a:spcPts val="600"/>
+              </a:spcAft>
+            </a:pPr>
+            <a:r>
+              <a:rPr sz="1500" b="0">
+                <a:solidFill>
+                  <a:srgbClr val="E8EEF4"/>
+                </a:solidFill>
+                <a:latin typeface="Microsoft YaHei"/>
+                <a:ea typeface="Microsoft YaHei"/>
+                <a:cs typeface="Microsoft YaHei"/>
+              </a:rPr>
+              <a:t>4) UC Q5_K_M 高画质无审查（新）：DiT 5.22GB，整包约 11.9GB。</a:t>
+            </a:r>
+          </a:p>
+          <a:p>
+            <a:pPr>
+              <a:spcAft>
+                <a:spcPts val="600"/>
+              </a:spcAft>
+            </a:pPr>
+            <a:r>
+              <a:rPr sz="1400" b="0">
+                <a:solidFill>
+                  <a:srgbClr val="9FB0C0"/>
+                </a:solidFill>
+                <a:latin typeface="Microsoft YaHei"/>
+                <a:ea typeface="Microsoft YaHei"/>
+                <a:cs typeface="Microsoft YaHei"/>
+              </a:rPr>
+              <a:t>四者共用 Qwen3-VL-8B 文本编码器 / mmproj / tokenizer / VAE，仅 DiT 权重不同；</a:t>
+            </a:r>
+          </a:p>
+          <a:p>
+            <a:pPr>
+              <a:spcAft>
+                <a:spcPts val="600"/>
+              </a:spcAft>
+            </a:pPr>
+            <a:r>
+              <a:rPr sz="1400" b="0">
+                <a:solidFill>
+                  <a:srgbClr val="9FB0C0"/>
+                </a:solidFill>
+                <a:latin typeface="Microsoft YaHei"/>
+                <a:ea typeface="Microsoft YaHei"/>
+                <a:cs typeface="Microsoft YaHei"/>
+              </a:rPr>
+              <a:t>各自独立下载目录、独立断点续传与完成标记；文件大小均在 hf-mirror 实测、支持 Range。</a:t>
+            </a:r>
+          </a:p>
+          <a:p>
+            <a:pPr>
+              <a:spcAft>
+                <a:spcPts val="600"/>
+              </a:spcAft>
+            </a:pPr>
+            <a:r>
+              <a:rPr sz="1400" b="0">
+                <a:solidFill>
+                  <a:srgbClr val="FBBF24"/>
+                </a:solidFill>
+                <a:latin typeface="Microsoft YaHei"/>
+                <a:ea typeface="Microsoft YaHei"/>
+                <a:cs typeface="Microsoft YaHei"/>
+              </a:rPr>
+              <a:t>机型门槛不变：骁龙8至尊版 SM8750+ / arm64 / Android12；32 位可见但锁定并说明（物理限制）。</a:t>
+            </a:r>
+          </a:p>
+          <a:p>
+            <a:pPr>
+              <a:spcAft>
+                <a:spcPts val="600"/>
+              </a:spcAft>
+            </a:pPr>
+            <a:r>
+              <a:rPr sz="1400" b="0">
+                <a:solidFill>
+                  <a:srgbClr val="9FB0C0"/>
+                </a:solidFill>
+                <a:latin typeface="Microsoft YaHei"/>
+                <a:ea typeface="Microsoft YaHei"/>
+                <a:cs typeface="Microsoft YaHei"/>
+              </a:rPr>
+              <a:t>其余沿用 et.18：NPU 全可见加锁、Illustrious v16、系统安装器直提、存储预检、MIT、dan.html 后台。</a:t>
             </a:r>
           </a:p>
         </p:txBody>

</xml_diff>

<commit_message>
et.20: fix safetensors native convert crash (length_error) on 32/64-bit, 6h wake lock, hide stats entry
- SafeTensorReader: validate header length and real file size, uint64 tensor size, fit_size guard, per-tensor buffer release
- main.cpp: catch length_error/bad_alloc in convert mode, emit CONVERT_FAILED instead of abort
- rebuild armv7 (NDK r25) and arm64 (NDK r29) cores; main.cpp -O1 to fit small build hosts (MNN stays -O3)
- BackgroundGenerationService wake lock 30m -> 6h so long CPU generations survive screen off
- build 94 / 3.0.0-et.20; gradle low-mem single JVM settings
- docs: et.20 notes, update.json 94, PPT/Word addendum, hide admin stats link (direct URL only)
</commit_message>
<xml_diff>
--- a/docs/LocalDream-ET_更新修复说明_et18.pptx
+++ b/docs/LocalDream-ET_更新修复说明_et18.pptx
@@ -20,6 +20,12 @@
     <p:sldId id="268" r:id="rId19"/>
     <p:sldId id="269" r:id="rId20"/>
     <p:sldId id="270" r:id="rId21"/>
+    <p:sldId id="271" r:id="rId22"/>
+    <p:sldId id="272" r:id="rId23"/>
+    <p:sldId id="273" r:id="rId24"/>
+    <p:sldId id="274" r:id="rId25"/>
+    <p:sldId id="275" r:id="rId26"/>
+    <p:sldId id="276" r:id="rId27"/>
   </p:sldIdLst>
   <p:sldSz cx="12191695" cy="6858000" type="screen4x3"/>
   <p:notesSz cx="6858000" cy="9144000"/>
@@ -4616,6 +4622,674 @@
 </p:sld>
 </file>
 
+<file path=ppt/slides/slide16.xml><?xml version="1.0" encoding="utf-8"?>
+<p:sld xmlns:a="http://schemas.openxmlformats.org/drawingml/2006/main" xmlns:p="http://schemas.openxmlformats.org/presentationml/2006/main" xmlns:r="http://schemas.openxmlformats.org/officeDocument/2006/relationships">
+  <p:cSld>
+    <p:spTree>
+      <p:nvGrpSpPr>
+        <p:cNvPr id="1" name=""/>
+        <p:cNvGrpSpPr/>
+        <p:nvPr/>
+      </p:nvGrpSpPr>
+      <p:grpSpPr/>
+      <p:sp>
+        <p:nvSpPr>
+          <p:cNvPr id="2" name="TextBox 1"/>
+          <p:cNvSpPr txBox="1"/>
+          <p:nvPr/>
+        </p:nvSpPr>
+        <p:spPr>
+          <a:xfrm>
+            <a:off x="548640" y="320040"/>
+            <a:ext cx="11064240" cy="914400"/>
+          </a:xfrm>
+          <a:prstGeom prst="rect">
+            <a:avLst/>
+          </a:prstGeom>
+          <a:noFill/>
+        </p:spPr>
+        <p:txBody>
+          <a:bodyPr wrap="square">
+            <a:spAutoFit/>
+          </a:bodyPr>
+          <a:lstStyle/>
+          <a:p>
+            <a:r>
+              <a:rPr sz="3000" b="1">
+                <a:solidFill>
+                  <a:srgbClr val="E88A6A"/>
+                </a:solidFill>
+                <a:latin typeface="Microsoft YaHei"/>
+              </a:rPr>
+              <a:t>v3.0.0-et.20（build 94）更新概览</a:t>
+            </a:r>
+          </a:p>
+        </p:txBody>
+      </p:sp>
+      <p:sp>
+        <p:nvSpPr>
+          <p:cNvPr id="3" name="TextBox 2"/>
+          <p:cNvSpPr txBox="1"/>
+          <p:nvPr/>
+        </p:nvSpPr>
+        <p:spPr>
+          <a:xfrm>
+            <a:off x="548640" y="1371600"/>
+            <a:ext cx="11064240" cy="5120640"/>
+          </a:xfrm>
+          <a:prstGeom prst="rect">
+            <a:avLst/>
+          </a:prstGeom>
+          <a:noFill/>
+        </p:spPr>
+        <p:txBody>
+          <a:bodyPr wrap="square">
+            <a:spAutoFit/>
+          </a:bodyPr>
+          <a:lstStyle/>
+          <a:p>
+            <a:pPr>
+              <a:spcAft>
+                <a:spcPts val="600"/>
+              </a:spcAft>
+            </a:pPr>
+            <a:r>
+              <a:rPr sz="1800">
+                <a:solidFill>
+                  <a:srgbClr val="222222"/>
+                </a:solidFill>
+                <a:latin typeface="Microsoft YaHei"/>
+              </a:rPr>
+              <a:t>• 修复 32 位/64 位本机转换模型闪退：std::length_error: vector / libc++abi 弹框</a:t>
+            </a:r>
+          </a:p>
+          <a:p>
+            <a:pPr>
+              <a:spcAft>
+                <a:spcPts val="600"/>
+              </a:spcAft>
+            </a:pPr>
+            <a:r>
+              <a:rPr sz="1800">
+                <a:solidFill>
+                  <a:srgbClr val="222222"/>
+                </a:solidFill>
+                <a:latin typeface="Microsoft YaHei"/>
+              </a:rPr>
+              <a:t>• 修复锁屏、切后台后生成图片中途被系统结束（唤醒锁 30 分钟→6 小时）</a:t>
+            </a:r>
+          </a:p>
+          <a:p>
+            <a:pPr>
+              <a:spcAft>
+                <a:spcPts val="600"/>
+              </a:spcAft>
+            </a:pPr>
+            <a:r>
+              <a:rPr sz="1800">
+                <a:solidFill>
+                  <a:srgbClr val="222222"/>
+                </a:solidFill>
+                <a:latin typeface="Microsoft YaHei"/>
+              </a:rPr>
+              <a:t>• 32 位 armeabi-v7a 与 64 位 arm64-v8a 原生引擎均重新编译内置</a:t>
+            </a:r>
+          </a:p>
+          <a:p>
+            <a:pPr>
+              <a:spcAft>
+                <a:spcPts val="600"/>
+              </a:spcAft>
+            </a:pPr>
+            <a:r>
+              <a:rPr sz="1800">
+                <a:solidFill>
+                  <a:srgbClr val="222222"/>
+                </a:solidFill>
+                <a:latin typeface="Microsoft YaHei"/>
+              </a:rPr>
+              <a:t>• 官网数据后台入口隐藏，仅管理员直链访问；更新文档错误码对照</a:t>
+            </a:r>
+          </a:p>
+          <a:p>
+            <a:pPr>
+              <a:spcAft>
+                <a:spcPts val="600"/>
+              </a:spcAft>
+            </a:pPr>
+            <a:r>
+              <a:rPr sz="1800">
+                <a:solidFill>
+                  <a:srgbClr val="222222"/>
+                </a:solidFill>
+                <a:latin typeface="Microsoft YaHei"/>
+              </a:rPr>
+              <a:t>• 沿用 et.19：千问 4 个量化版本、Illustrious v16、NPU 按机型加锁、MIT</a:t>
+            </a:r>
+          </a:p>
+        </p:txBody>
+      </p:sp>
+    </p:spTree>
+  </p:cSld>
+  <p:clrMapOvr>
+    <a:masterClrMapping/>
+  </p:clrMapOvr>
+</p:sld>
+</file>
+
+<file path=ppt/slides/slide17.xml><?xml version="1.0" encoding="utf-8"?>
+<p:sld xmlns:a="http://schemas.openxmlformats.org/drawingml/2006/main" xmlns:p="http://schemas.openxmlformats.org/presentationml/2006/main" xmlns:r="http://schemas.openxmlformats.org/officeDocument/2006/relationships">
+  <p:cSld>
+    <p:spTree>
+      <p:nvGrpSpPr>
+        <p:cNvPr id="1" name=""/>
+        <p:cNvGrpSpPr/>
+        <p:nvPr/>
+      </p:nvGrpSpPr>
+      <p:grpSpPr/>
+      <p:sp>
+        <p:nvSpPr>
+          <p:cNvPr id="2" name="TextBox 1"/>
+          <p:cNvSpPr txBox="1"/>
+          <p:nvPr/>
+        </p:nvSpPr>
+        <p:spPr>
+          <a:xfrm>
+            <a:off x="548640" y="320040"/>
+            <a:ext cx="11064240" cy="914400"/>
+          </a:xfrm>
+          <a:prstGeom prst="rect">
+            <a:avLst/>
+          </a:prstGeom>
+          <a:noFill/>
+        </p:spPr>
+        <p:txBody>
+          <a:bodyPr wrap="square">
+            <a:spAutoFit/>
+          </a:bodyPr>
+          <a:lstStyle/>
+          <a:p>
+            <a:r>
+              <a:rPr sz="3000" b="1">
+                <a:solidFill>
+                  <a:srgbClr val="E88A6A"/>
+                </a:solidFill>
+                <a:latin typeface="Microsoft YaHei"/>
+              </a:rPr>
+              <a:t>根因：转换崩溃 length_error</a:t>
+            </a:r>
+          </a:p>
+        </p:txBody>
+      </p:sp>
+      <p:sp>
+        <p:nvSpPr>
+          <p:cNvPr id="3" name="TextBox 2"/>
+          <p:cNvSpPr txBox="1"/>
+          <p:nvPr/>
+        </p:nvSpPr>
+        <p:spPr>
+          <a:xfrm>
+            <a:off x="548640" y="1371600"/>
+            <a:ext cx="11064240" cy="5120640"/>
+          </a:xfrm>
+          <a:prstGeom prst="rect">
+            <a:avLst/>
+          </a:prstGeom>
+          <a:noFill/>
+        </p:spPr>
+        <p:txBody>
+          <a:bodyPr wrap="square">
+            <a:spAutoFit/>
+          </a:bodyPr>
+          <a:lstStyle/>
+          <a:p>
+            <a:pPr>
+              <a:spcAft>
+                <a:spcPts val="600"/>
+              </a:spcAft>
+            </a:pPr>
+            <a:r>
+              <a:rPr sz="1800">
+                <a:solidFill>
+                  <a:srgbClr val="222222"/>
+                </a:solidFill>
+                <a:latin typeface="Microsoft YaHei"/>
+              </a:rPr>
+              <a:t>• 现象：本机转换 safetensors→MNN 时直接 abort，弹 libc++abi 框后退出码 134</a:t>
+            </a:r>
+          </a:p>
+          <a:p>
+            <a:pPr>
+              <a:spcAft>
+                <a:spcPts val="600"/>
+              </a:spcAft>
+            </a:pPr>
+            <a:r>
+              <a:rPr sz="1800">
+                <a:solidFill>
+                  <a:srgbClr val="222222"/>
+                </a:solidFill>
+                <a:latin typeface="Microsoft YaHei"/>
+              </a:rPr>
+              <a:t>• 根因 1：文件头前 8 字节被直接当作 header 长度并分配内存，未校验</a:t>
+            </a:r>
+          </a:p>
+          <a:p>
+            <a:pPr>
+              <a:spcAft>
+                <a:spcPts val="600"/>
+              </a:spcAft>
+            </a:pPr>
+            <a:r>
+              <a:rPr sz="1500">
+                <a:solidFill>
+                  <a:srgbClr val="222222"/>
+                </a:solidFill>
+                <a:latin typeface="Microsoft YaHei"/>
+              </a:rPr>
+              <a:t>    – 文件损坏/截断、实为 .ckpt、下到 HTML 错误页时，该值是天文数字，32 位立即 length_error</a:t>
+            </a:r>
+          </a:p>
+          <a:p>
+            <a:pPr>
+              <a:spcAft>
+                <a:spcPts val="600"/>
+              </a:spcAft>
+            </a:pPr>
+            <a:r>
+              <a:rPr sz="1800">
+                <a:solidFill>
+                  <a:srgbClr val="222222"/>
+                </a:solidFill>
+                <a:latin typeface="Microsoft YaHei"/>
+              </a:rPr>
+              <a:t>• 根因 2：张量元素数用 int 累乘 shape，大张量大值溢出</a:t>
+            </a:r>
+          </a:p>
+          <a:p>
+            <a:pPr>
+              <a:spcAft>
+                <a:spcPts val="600"/>
+              </a:spcAft>
+            </a:pPr>
+            <a:r>
+              <a:rPr sz="1800">
+                <a:solidFill>
+                  <a:srgbClr val="222222"/>
+                </a:solidFill>
+                <a:latin typeface="Microsoft YaHei"/>
+              </a:rPr>
+              <a:t>• 根因 3：转换入口无 try/catch，任何 C++ 异常直接 std::terminate</a:t>
+            </a:r>
+          </a:p>
+          <a:p>
+            <a:pPr>
+              <a:spcAft>
+                <a:spcPts val="600"/>
+              </a:spcAft>
+            </a:pPr>
+            <a:r>
+              <a:rPr sz="1800">
+                <a:solidFill>
+                  <a:srgbClr val="222222"/>
+                </a:solidFill>
+                <a:latin typeface="Microsoft YaHei"/>
+              </a:rPr>
+              <a:t>• 根因 4：reader 成员缓存跨张量不清空，峰值内存随张量累积</a:t>
+            </a:r>
+          </a:p>
+        </p:txBody>
+      </p:sp>
+    </p:spTree>
+  </p:cSld>
+  <p:clrMapOvr>
+    <a:masterClrMapping/>
+  </p:clrMapOvr>
+</p:sld>
+</file>
+
+<file path=ppt/slides/slide18.xml><?xml version="1.0" encoding="utf-8"?>
+<p:sld xmlns:a="http://schemas.openxmlformats.org/drawingml/2006/main" xmlns:p="http://schemas.openxmlformats.org/presentationml/2006/main" xmlns:r="http://schemas.openxmlformats.org/officeDocument/2006/relationships">
+  <p:cSld>
+    <p:spTree>
+      <p:nvGrpSpPr>
+        <p:cNvPr id="1" name=""/>
+        <p:cNvGrpSpPr/>
+        <p:nvPr/>
+      </p:nvGrpSpPr>
+      <p:grpSpPr/>
+      <p:sp>
+        <p:nvSpPr>
+          <p:cNvPr id="2" name="TextBox 1"/>
+          <p:cNvSpPr txBox="1"/>
+          <p:nvPr/>
+        </p:nvSpPr>
+        <p:spPr>
+          <a:xfrm>
+            <a:off x="548640" y="320040"/>
+            <a:ext cx="11064240" cy="914400"/>
+          </a:xfrm>
+          <a:prstGeom prst="rect">
+            <a:avLst/>
+          </a:prstGeom>
+          <a:noFill/>
+        </p:spPr>
+        <p:txBody>
+          <a:bodyPr wrap="square">
+            <a:spAutoFit/>
+          </a:bodyPr>
+          <a:lstStyle/>
+          <a:p>
+            <a:r>
+              <a:rPr sz="3000" b="1">
+                <a:solidFill>
+                  <a:srgbClr val="E88A6A"/>
+                </a:solidFill>
+                <a:latin typeface="Microsoft YaHei"/>
+              </a:rPr>
+              <a:t>修复：SafeTensorReader 加固（双架构）</a:t>
+            </a:r>
+          </a:p>
+        </p:txBody>
+      </p:sp>
+      <p:sp>
+        <p:nvSpPr>
+          <p:cNvPr id="3" name="TextBox 2"/>
+          <p:cNvSpPr txBox="1"/>
+          <p:nvPr/>
+        </p:nvSpPr>
+        <p:spPr>
+          <a:xfrm>
+            <a:off x="548640" y="1371600"/>
+            <a:ext cx="11064240" cy="5120640"/>
+          </a:xfrm>
+          <a:prstGeom prst="rect">
+            <a:avLst/>
+          </a:prstGeom>
+          <a:noFill/>
+        </p:spPr>
+        <p:txBody>
+          <a:bodyPr wrap="square">
+            <a:spAutoFit/>
+          </a:bodyPr>
+          <a:lstStyle/>
+          <a:p>
+            <a:pPr>
+              <a:spcAft>
+                <a:spcPts val="600"/>
+              </a:spcAft>
+            </a:pPr>
+            <a:r>
+              <a:rPr sz="1800">
+                <a:solidFill>
+                  <a:srgbClr val="222222"/>
+                </a:solidFill>
+                <a:latin typeface="Microsoft YaHei"/>
+              </a:rPr>
+              <a:t>• header 长度合法性校验：非 0 且 ≤256MB，否则报非法 safetensors</a:t>
+            </a:r>
+          </a:p>
+          <a:p>
+            <a:pPr>
+              <a:spcAft>
+                <a:spcPts val="600"/>
+              </a:spcAft>
+            </a:pPr>
+            <a:r>
+              <a:rPr sz="1800">
+                <a:solidFill>
+                  <a:srgbClr val="222222"/>
+                </a:solidFill>
+                <a:latin typeface="Microsoft YaHei"/>
+              </a:rPr>
+              <a:t>• seekg/tellg 取真实文件大小，校验 file_size ≥ 8+header，截断即报错</a:t>
+            </a:r>
+          </a:p>
+          <a:p>
+            <a:pPr>
+              <a:spcAft>
+                <a:spcPts val="600"/>
+              </a:spcAft>
+            </a:pPr>
+            <a:r>
+              <a:rPr sz="1800">
+                <a:solidFill>
+                  <a:srgbClr val="222222"/>
+                </a:solidFill>
+                <a:latin typeface="Microsoft YaHei"/>
+              </a:rPr>
+              <a:t>• 元素数改 uint64_t 累乘，含负维与 64 位溢出检查</a:t>
+            </a:r>
+          </a:p>
+          <a:p>
+            <a:pPr>
+              <a:spcAft>
+                <a:spcPts val="600"/>
+              </a:spcAft>
+            </a:pPr>
+            <a:r>
+              <a:rPr sz="1800">
+                <a:solidFill>
+                  <a:srgbClr val="222222"/>
+                </a:solidFill>
+                <a:latin typeface="Microsoft YaHei"/>
+              </a:rPr>
+              <a:t>• 新增 fit_size()：超过 32 位进程 size_t 上限时抛出可读错误</a:t>
+            </a:r>
+          </a:p>
+          <a:p>
+            <a:pPr>
+              <a:spcAft>
+                <a:spcPts val="600"/>
+              </a:spcAft>
+            </a:pPr>
+            <a:r>
+              <a:rPr sz="1800">
+                <a:solidFill>
+                  <a:srgbClr val="222222"/>
+                </a:solidFill>
+                <a:latin typeface="Microsoft YaHei"/>
+              </a:rPr>
+              <a:t>• 每张量读取前 vector().swap() 释放上一块，峰值内存只留一个张量</a:t>
+            </a:r>
+          </a:p>
+          <a:p>
+            <a:pPr>
+              <a:spcAft>
+                <a:spcPts val="600"/>
+              </a:spcAft>
+            </a:pPr>
+            <a:r>
+              <a:rPr sz="1800">
+                <a:solidFill>
+                  <a:srgbClr val="222222"/>
+                </a:solidFill>
+                <a:latin typeface="Microsoft YaHei"/>
+              </a:rPr>
+              <a:t>• 偏移/字节数统一 int64/uint64，消除有符号溢出</a:t>
+            </a:r>
+          </a:p>
+        </p:txBody>
+      </p:sp>
+    </p:spTree>
+  </p:cSld>
+  <p:clrMapOvr>
+    <a:masterClrMapping/>
+  </p:clrMapOvr>
+</p:sld>
+</file>
+
+<file path=ppt/slides/slide19.xml><?xml version="1.0" encoding="utf-8"?>
+<p:sld xmlns:a="http://schemas.openxmlformats.org/drawingml/2006/main" xmlns:p="http://schemas.openxmlformats.org/presentationml/2006/main" xmlns:r="http://schemas.openxmlformats.org/officeDocument/2006/relationships">
+  <p:cSld>
+    <p:spTree>
+      <p:nvGrpSpPr>
+        <p:cNvPr id="1" name=""/>
+        <p:cNvGrpSpPr/>
+        <p:nvPr/>
+      </p:nvGrpSpPr>
+      <p:grpSpPr/>
+      <p:sp>
+        <p:nvSpPr>
+          <p:cNvPr id="2" name="TextBox 1"/>
+          <p:cNvSpPr txBox="1"/>
+          <p:nvPr/>
+        </p:nvSpPr>
+        <p:spPr>
+          <a:xfrm>
+            <a:off x="548640" y="320040"/>
+            <a:ext cx="11064240" cy="914400"/>
+          </a:xfrm>
+          <a:prstGeom prst="rect">
+            <a:avLst/>
+          </a:prstGeom>
+          <a:noFill/>
+        </p:spPr>
+        <p:txBody>
+          <a:bodyPr wrap="square">
+            <a:spAutoFit/>
+          </a:bodyPr>
+          <a:lstStyle/>
+          <a:p>
+            <a:r>
+              <a:rPr sz="3000" b="1">
+                <a:solidFill>
+                  <a:srgbClr val="E88A6A"/>
+                </a:solidFill>
+                <a:latin typeface="Microsoft YaHei"/>
+              </a:rPr>
+              <a:t>修复：异常捕获与后台稳定性</a:t>
+            </a:r>
+          </a:p>
+        </p:txBody>
+      </p:sp>
+      <p:sp>
+        <p:nvSpPr>
+          <p:cNvPr id="3" name="TextBox 2"/>
+          <p:cNvSpPr txBox="1"/>
+          <p:nvPr/>
+        </p:nvSpPr>
+        <p:spPr>
+          <a:xfrm>
+            <a:off x="548640" y="1371600"/>
+            <a:ext cx="11064240" cy="5120640"/>
+          </a:xfrm>
+          <a:prstGeom prst="rect">
+            <a:avLst/>
+          </a:prstGeom>
+          <a:noFill/>
+        </p:spPr>
+        <p:txBody>
+          <a:bodyPr wrap="square">
+            <a:spAutoFit/>
+          </a:bodyPr>
+          <a:lstStyle/>
+          <a:p>
+            <a:pPr>
+              <a:spcAft>
+                <a:spcPts val="600"/>
+              </a:spcAft>
+            </a:pPr>
+            <a:r>
+              <a:rPr sz="1800">
+                <a:solidFill>
+                  <a:srgbClr val="222222"/>
+                </a:solidFill>
+                <a:latin typeface="Microsoft YaHei"/>
+              </a:rPr>
+              <a:t>• main.cpp 转换模式包 try/catch：length_error / bad_alloc / std::exception</a:t>
+            </a:r>
+          </a:p>
+          <a:p>
+            <a:pPr>
+              <a:spcAft>
+                <a:spcPts val="600"/>
+              </a:spcAft>
+            </a:pPr>
+            <a:r>
+              <a:rPr sz="1500">
+                <a:solidFill>
+                  <a:srgbClr val="222222"/>
+                </a:solidFill>
+                <a:latin typeface="Microsoft YaHei"/>
+              </a:rPr>
+              <a:t>    – 统一输出 CONVERT_FAILED: &lt;原因&gt; 并返回失败码，不再闪退弹原生框</a:t>
+            </a:r>
+          </a:p>
+          <a:p>
+            <a:pPr>
+              <a:spcAft>
+                <a:spcPts val="600"/>
+              </a:spcAft>
+            </a:pPr>
+            <a:r>
+              <a:rPr sz="1800">
+                <a:solidFill>
+                  <a:srgbClr val="222222"/>
+                </a:solidFill>
+                <a:latin typeface="Microsoft YaHei"/>
+              </a:rPr>
+              <a:t>• BackgroundGenerationService 唤醒锁 30 分钟→6 小时</a:t>
+            </a:r>
+          </a:p>
+          <a:p>
+            <a:pPr>
+              <a:spcAft>
+                <a:spcPts val="600"/>
+              </a:spcAft>
+            </a:pPr>
+            <a:r>
+              <a:rPr sz="1500">
+                <a:solidFill>
+                  <a:srgbClr val="222222"/>
+                </a:solidFill>
+                <a:latin typeface="Microsoft YaHei"/>
+              </a:rPr>
+              <a:t>    – 老旧 32 位 CPU 单张 20–60 分钟，原 30 分钟到期 CPU 休眠即中断</a:t>
+            </a:r>
+          </a:p>
+          <a:p>
+            <a:pPr>
+              <a:spcAft>
+                <a:spcPts val="600"/>
+              </a:spcAft>
+            </a:pPr>
+            <a:r>
+              <a:rPr sz="1800">
+                <a:solidFill>
+                  <a:srgbClr val="222222"/>
+                </a:solidFill>
+                <a:latin typeface="Microsoft YaHei"/>
+              </a:rPr>
+              <a:t>• onDestroy 仍正常释放唤醒锁，不额外耗电</a:t>
+            </a:r>
+          </a:p>
+          <a:p>
+            <a:pPr>
+              <a:spcAft>
+                <a:spcPts val="600"/>
+              </a:spcAft>
+            </a:pPr>
+            <a:r>
+              <a:rPr sz="1800">
+                <a:solidFill>
+                  <a:srgbClr val="222222"/>
+                </a:solidFill>
+                <a:latin typeface="Microsoft YaHei"/>
+              </a:rPr>
+              <a:t>• 下载侧已对 .part 做 contentLength 截断+非空校验，保留断点续传，与文件头校验双重防损坏</a:t>
+            </a:r>
+          </a:p>
+        </p:txBody>
+      </p:sp>
+    </p:spTree>
+  </p:cSld>
+  <p:clrMapOvr>
+    <a:masterClrMapping/>
+  </p:clrMapOvr>
+</p:sld>
+</file>
+
 <file path=ppt/slides/slide2.xml><?xml version="1.0" encoding="utf-8"?>
 <p:sld xmlns:a="http://schemas.openxmlformats.org/drawingml/2006/main" xmlns:p="http://schemas.openxmlformats.org/presentationml/2006/main" xmlns:r="http://schemas.openxmlformats.org/officeDocument/2006/relationships">
   <p:cSld>
@@ -4762,6 +5436,364 @@
                 <a:cs typeface="Microsoft YaHei"/>
               </a:rPr>
               <a:t>et.18 在 et.17 基础上：NPU 模型全可见并加锁、安装器直提系统、MIT 许可、官网数据后台</a:t>
+            </a:r>
+          </a:p>
+        </p:txBody>
+      </p:sp>
+    </p:spTree>
+  </p:cSld>
+  <p:clrMapOvr>
+    <a:masterClrMapping/>
+  </p:clrMapOvr>
+</p:sld>
+</file>
+
+<file path=ppt/slides/slide20.xml><?xml version="1.0" encoding="utf-8"?>
+<p:sld xmlns:a="http://schemas.openxmlformats.org/drawingml/2006/main" xmlns:p="http://schemas.openxmlformats.org/presentationml/2006/main" xmlns:r="http://schemas.openxmlformats.org/officeDocument/2006/relationships">
+  <p:cSld>
+    <p:spTree>
+      <p:nvGrpSpPr>
+        <p:cNvPr id="1" name=""/>
+        <p:cNvGrpSpPr/>
+        <p:nvPr/>
+      </p:nvGrpSpPr>
+      <p:grpSpPr/>
+      <p:sp>
+        <p:nvSpPr>
+          <p:cNvPr id="2" name="TextBox 1"/>
+          <p:cNvSpPr txBox="1"/>
+          <p:nvPr/>
+        </p:nvSpPr>
+        <p:spPr>
+          <a:xfrm>
+            <a:off x="548640" y="320040"/>
+            <a:ext cx="11064240" cy="914400"/>
+          </a:xfrm>
+          <a:prstGeom prst="rect">
+            <a:avLst/>
+          </a:prstGeom>
+          <a:noFill/>
+        </p:spPr>
+        <p:txBody>
+          <a:bodyPr wrap="square">
+            <a:spAutoFit/>
+          </a:bodyPr>
+          <a:lstStyle/>
+          <a:p>
+            <a:r>
+              <a:rPr sz="3000" b="1">
+                <a:solidFill>
+                  <a:srgbClr val="E88A6A"/>
+                </a:solidFill>
+                <a:latin typeface="Microsoft YaHei"/>
+              </a:rPr>
+              <a:t>双架构原生引擎重编</a:t>
+            </a:r>
+          </a:p>
+        </p:txBody>
+      </p:sp>
+      <p:sp>
+        <p:nvSpPr>
+          <p:cNvPr id="3" name="TextBox 2"/>
+          <p:cNvSpPr txBox="1"/>
+          <p:nvPr/>
+        </p:nvSpPr>
+        <p:spPr>
+          <a:xfrm>
+            <a:off x="548640" y="1371600"/>
+            <a:ext cx="11064240" cy="5120640"/>
+          </a:xfrm>
+          <a:prstGeom prst="rect">
+            <a:avLst/>
+          </a:prstGeom>
+          <a:noFill/>
+        </p:spPr>
+        <p:txBody>
+          <a:bodyPr wrap="square">
+            <a:spAutoFit/>
+          </a:bodyPr>
+          <a:lstStyle/>
+          <a:p>
+            <a:pPr>
+              <a:spcAft>
+                <a:spcPts val="600"/>
+              </a:spcAft>
+            </a:pPr>
+            <a:r>
+              <a:rPr sz="1800">
+                <a:solidFill>
+                  <a:srgbClr val="222222"/>
+                </a:solidFill>
+                <a:latin typeface="Microsoft YaHei"/>
+              </a:rPr>
+              <a:t>• armeabi-v7a：NDK r25 编译成功，ELF32 ARM，约 7.8MB，纯 CPU/GPU</a:t>
+            </a:r>
+          </a:p>
+          <a:p>
+            <a:pPr>
+              <a:spcAft>
+                <a:spcPts val="600"/>
+              </a:spcAft>
+            </a:pPr>
+            <a:r>
+              <a:rPr sz="1800">
+                <a:solidFill>
+                  <a:srgbClr val="222222"/>
+                </a:solidFill>
+                <a:latin typeface="Microsoft YaHei"/>
+              </a:rPr>
+              <a:t>• arm64-v8a：NDK r29 编译成功，ELF64 AArch64，约 11.2MB</a:t>
+            </a:r>
+          </a:p>
+          <a:p>
+            <a:pPr>
+              <a:spcAft>
+                <a:spcPts val="600"/>
+              </a:spcAft>
+            </a:pPr>
+            <a:r>
+              <a:rPr sz="1500">
+                <a:solidFill>
+                  <a:srgbClr val="222222"/>
+                </a:solidFill>
+                <a:latin typeface="Microsoft YaHei"/>
+              </a:rPr>
+              <a:t>    – r25 编译 MNN Arm82 FP16 内联报错（vfmlalq_*），必须用 r29</a:t>
+            </a:r>
+          </a:p>
+          <a:p>
+            <a:pPr>
+              <a:spcAft>
+                <a:spcPts val="600"/>
+              </a:spcAft>
+            </a:pPr>
+            <a:r>
+              <a:rPr sz="1500">
+                <a:solidFill>
+                  <a:srgbClr val="222222"/>
+                </a:solidFill>
+                <a:latin typeface="Microsoft YaHei"/>
+              </a:rPr>
+              <a:t>    – main.cpp 为超大 xtensor 单元，单独 -O1（热点在 MNN 仍 -O3，不影响出图速度）</a:t>
+            </a:r>
+          </a:p>
+          <a:p>
+            <a:pPr>
+              <a:spcAft>
+                <a:spcPts val="600"/>
+              </a:spcAft>
+            </a:pPr>
+            <a:r>
+              <a:rPr sz="1800">
+                <a:solidFill>
+                  <a:srgbClr val="222222"/>
+                </a:solidFill>
+                <a:latin typeface="Microsoft YaHei"/>
+              </a:rPr>
+              <a:t>• QNN NPU 运行库 20 个 .so 走 assets 运行时 dlopen，NPU 能力等价保留</a:t>
+            </a:r>
+          </a:p>
+          <a:p>
+            <a:pPr>
+              <a:spcAft>
+                <a:spcPts val="600"/>
+              </a:spcAft>
+            </a:pPr>
+            <a:r>
+              <a:rPr sz="1800">
+                <a:solidFill>
+                  <a:srgbClr val="222222"/>
+                </a:solidFill>
+                <a:latin typeface="Microsoft YaHei"/>
+              </a:rPr>
+              <a:t>• APK 已校验：签名 CN=ET(Meizhou)、versionCode 94、双 ABI、ZIP 完整</a:t>
+            </a:r>
+          </a:p>
+        </p:txBody>
+      </p:sp>
+    </p:spTree>
+  </p:cSld>
+  <p:clrMapOvr>
+    <a:masterClrMapping/>
+  </p:clrMapOvr>
+</p:sld>
+</file>
+
+<file path=ppt/slides/slide21.xml><?xml version="1.0" encoding="utf-8"?>
+<p:sld xmlns:a="http://schemas.openxmlformats.org/drawingml/2006/main" xmlns:p="http://schemas.openxmlformats.org/presentationml/2006/main" xmlns:r="http://schemas.openxmlformats.org/officeDocument/2006/relationships">
+  <p:cSld>
+    <p:spTree>
+      <p:nvGrpSpPr>
+        <p:cNvPr id="1" name=""/>
+        <p:cNvGrpSpPr/>
+        <p:nvPr/>
+      </p:nvGrpSpPr>
+      <p:grpSpPr/>
+      <p:sp>
+        <p:nvSpPr>
+          <p:cNvPr id="2" name="TextBox 1"/>
+          <p:cNvSpPr txBox="1"/>
+          <p:nvPr/>
+        </p:nvSpPr>
+        <p:spPr>
+          <a:xfrm>
+            <a:off x="548640" y="320040"/>
+            <a:ext cx="11064240" cy="914400"/>
+          </a:xfrm>
+          <a:prstGeom prst="rect">
+            <a:avLst/>
+          </a:prstGeom>
+          <a:noFill/>
+        </p:spPr>
+        <p:txBody>
+          <a:bodyPr wrap="square">
+            <a:spAutoFit/>
+          </a:bodyPr>
+          <a:lstStyle/>
+          <a:p>
+            <a:r>
+              <a:rPr sz="3000" b="1">
+                <a:solidFill>
+                  <a:srgbClr val="E88A6A"/>
+                </a:solidFill>
+                <a:latin typeface="Microsoft YaHei"/>
+              </a:rPr>
+              <a:t>物理限制与真机验收说明</a:t>
+            </a:r>
+          </a:p>
+        </p:txBody>
+      </p:sp>
+      <p:sp>
+        <p:nvSpPr>
+          <p:cNvPr id="3" name="TextBox 2"/>
+          <p:cNvSpPr txBox="1"/>
+          <p:nvPr/>
+        </p:nvSpPr>
+        <p:spPr>
+          <a:xfrm>
+            <a:off x="548640" y="1371600"/>
+            <a:ext cx="11064240" cy="5120640"/>
+          </a:xfrm>
+          <a:prstGeom prst="rect">
+            <a:avLst/>
+          </a:prstGeom>
+          <a:noFill/>
+        </p:spPr>
+        <p:txBody>
+          <a:bodyPr wrap="square">
+            <a:spAutoFit/>
+          </a:bodyPr>
+          <a:lstStyle/>
+          <a:p>
+            <a:pPr>
+              <a:spcAft>
+                <a:spcPts val="600"/>
+              </a:spcAft>
+            </a:pPr>
+            <a:r>
+              <a:rPr sz="1800">
+                <a:solidFill>
+                  <a:srgbClr val="222222"/>
+                </a:solidFill>
+                <a:latin typeface="Microsoft YaHei"/>
+              </a:rPr>
+              <a:t>• 32 位无法运行 SDXL / Illustrious / 千问 / 4K：引擎仅 arm64 且需高通 NPU</a:t>
+            </a:r>
+          </a:p>
+          <a:p>
+            <a:pPr>
+              <a:spcAft>
+                <a:spcPts val="600"/>
+              </a:spcAft>
+            </a:pPr>
+            <a:r>
+              <a:rPr sz="1800">
+                <a:solidFill>
+                  <a:srgbClr val="222222"/>
+                </a:solidFill>
+                <a:latin typeface="Microsoft YaHei"/>
+              </a:rPr>
+              <a:t>• 千问门槛：骁龙 8 至尊版 SM8750+ / arm64 / Android12 / RAM 12GB</a:t>
+            </a:r>
+          </a:p>
+          <a:p>
+            <a:pPr>
+              <a:spcAft>
+                <a:spcPts val="600"/>
+              </a:spcAft>
+            </a:pPr>
+            <a:r>
+              <a:rPr sz="1800">
+                <a:solidFill>
+                  <a:srgbClr val="222222"/>
+                </a:solidFill>
+                <a:latin typeface="Microsoft YaHei"/>
+              </a:rPr>
+              <a:t>• Illustrious、SDXL：SM8650+ arm64 Android12；豆包无本地权重，不提供</a:t>
+            </a:r>
+          </a:p>
+          <a:p>
+            <a:pPr>
+              <a:spcAft>
+                <a:spcPts val="600"/>
+              </a:spcAft>
+            </a:pPr>
+            <a:r>
+              <a:rPr sz="1800">
+                <a:solidFill>
+                  <a:srgbClr val="222222"/>
+                </a:solidFill>
+                <a:latin typeface="Microsoft YaHei"/>
+              </a:rPr>
+              <a:t>• 老旧 32 位 CPU 出图 20 分–1 小时属像素平方增长的物理耗时</a:t>
+            </a:r>
+          </a:p>
+          <a:p>
+            <a:pPr>
+              <a:spcAft>
+                <a:spcPts val="600"/>
+              </a:spcAft>
+            </a:pPr>
+            <a:r>
+              <a:rPr sz="1800">
+                <a:solidFill>
+                  <a:srgbClr val="222222"/>
+                </a:solidFill>
+                <a:latin typeface="Microsoft YaHei"/>
+              </a:rPr>
+              <a:t>• 应用无独立图片反推(tagger)端点；用户所说“反推”走图生图/编辑流程</a:t>
+            </a:r>
+          </a:p>
+          <a:p>
+            <a:pPr>
+              <a:spcAft>
+                <a:spcPts val="600"/>
+              </a:spcAft>
+            </a:pPr>
+            <a:r>
+              <a:rPr sz="1800">
+                <a:solidFill>
+                  <a:srgbClr val="222222"/>
+                </a:solidFill>
+                <a:latin typeface="Microsoft YaHei"/>
+              </a:rPr>
+              <a:t>• 沙箱为 Linux x86，无 ARM 真机，端到端下模型/转换/出图需真机验收</a:t>
+            </a:r>
+          </a:p>
+          <a:p>
+            <a:pPr>
+              <a:spcAft>
+                <a:spcPts val="600"/>
+              </a:spcAft>
+            </a:pPr>
+            <a:r>
+              <a:rPr sz="1800">
+                <a:solidFill>
+                  <a:srgbClr val="222222"/>
+                </a:solidFill>
+                <a:latin typeface="Microsoft YaHei"/>
+              </a:rPr>
+              <a:t>• 报错请提供英文原文+退出码+机型/SoC/Android/32or64/模型 id</a:t>
             </a:r>
           </a:p>
         </p:txBody>

</xml_diff>